<commit_message>
fix: auditar desempeño por customer_state y corregir cifra de iteraciones del modelo
NB2 §5.2 ahora calcula el desempeño real por customer_state (antes solo se
afirmaba sin evidencia en el Informe/Presentación); model_card.json persiste
n_iter_actual (62 rondas de boosting reales, vs. el techo max_iter=150 del
espacio de búsqueda que se citaba por error). Informe Técnico y Presentación
actualizados para reportar ambos hallazgos reales, con la salvedad de los
estados sin casos positivos en test. Ninguna métrica global (PR-AUC/ROC-AUC/
Brier/lift) cambió al re-ejecutar NB2.

Co-Authored-By: Claude Sonnet 5 <noreply@anthropic.com>
</commit_message>
<xml_diff>
--- a/docs/Defensa_ShopMart_Olist.pptx
+++ b/docs/Defensa_ShopMart_Olist.pptx
@@ -4904,15 +4904,15 @@
             </a:pPr>
             <a:endParaRPr lang="en-US" sz="1200" dirty="0"/>
             <a:r>
-              <a:rPr lang="en-US" sz="1200" dirty="0">
-                <a:solidFill>
-                  <a:srgbClr val="475569"/>
-                </a:solidFill>
-                <a:latin typeface="Arial" pitchFamily="34" charset="0"/>
-                <a:ea typeface="Arial" pitchFamily="34" charset="-122"/>
-                <a:cs typeface="Arial" pitchFamily="34" charset="-120"/>
-              </a:rPr>
-              <a:t>Sin degradación sistemática por categoría o customer_state, pero el volumen por subgrupo es limitado — estas estimaciones son orientativas, no concluyentes.</a:t>
+              <a:rPr lang="en-US" sz="1200" dirty="0" b="0">
+                <a:solidFill>
+                  <a:srgbClr val="475569"/>
+                </a:solidFill>
+                <a:latin typeface="Arial" pitchFamily="34" charset="0"/>
+                <a:ea typeface="Arial" pitchFamily="34" charset="-122"/>
+                <a:cs typeface="Arial" pitchFamily="34" charset="-120"/>
+              </a:rPr>
+              <a:t>Por categoría, sin degradación sistemática. Por customer_state, PR-AUC 0.025–0.208 en 24 de 27 estados; 3 sin casos de recompra en test quedan sin evaluar — orientativo.</a:t>
             </a:r>
           </a:p>
         </p:txBody>
@@ -5583,7 +5583,7 @@
                 <a:ea typeface="Arial" pitchFamily="34" charset="-122"/>
                 <a:cs typeface="Arial" pitchFamily="34" charset="-120"/>
               </a:rPr>
-              <a:t>Latencia: milisegundos por registro — modelo liviano (150 iteraciones), compatible con un endpoint síncrono.</a:t>
+              <a:t>Latencia: milisegundos por registro — modelo liviano (62 rondas de boosting entrenadas, techo buscado de 150), compatible con un endpoint síncrono.</a:t>
             </a:r>
           </a:p>
           <a:p>
@@ -5851,15 +5851,15 @@
             </a:pPr>
             <a:endParaRPr lang="en-US" sz="1200" dirty="0"/>
             <a:r>
-              <a:rPr lang="en-US" sz="1200" dirty="0">
-                <a:solidFill>
-                  <a:srgbClr val="475569"/>
-                </a:solidFill>
-                <a:latin typeface="Arial" pitchFamily="34" charset="0"/>
-                <a:ea typeface="Arial" pitchFamily="34" charset="-122"/>
-                <a:cs typeface="Arial" pitchFamily="34" charset="-120"/>
-              </a:rPr>
-              <a:t>Sin disparidades severas por categoría o estado, aunque el tamaño muestral por subgrupo es limitado — se recomienda monitorear esta métrica en producción.</a:t>
+              <a:rPr lang="en-US" sz="1200" dirty="0" b="0">
+                <a:solidFill>
+                  <a:srgbClr val="475569"/>
+                </a:solidFill>
+                <a:latin typeface="Arial" pitchFamily="34" charset="0"/>
+                <a:ea typeface="Arial" pitchFamily="34" charset="-122"/>
+                <a:cs typeface="Arial" pitchFamily="34" charset="-120"/>
+              </a:rPr>
+              <a:t>Por categoría y por customer_state, PR-AUC 0.025–0.208 en 24 de 27 estados, sin disparidad severa; 3 sin casos de recompra quedan sin evaluar — monitorear en producción.</a:t>
             </a:r>
           </a:p>
         </p:txBody>

</xml_diff>